<commit_message>
0.6.0: folders like Jupyter, tabs, one model across diagrams, checks, PlantUML in, company colours
- The list is a file browser: folders are projects, every file shows; tabs for open diagrams
- Sequence diagrams know the folder's class diagrams: suggestions, marks, one-click fixes
- UML checks on use case, class, activity, state and communication diagrams
- Class and use case diagrams can be typed as PlantUML
- Per-folder colour palettes (presets, hex codes, from a logo), Colour by kind
- Diagrams fill the window and keep fitting as it changes size
- Fixes from review: listing races with moves, folder delete keeps hidden files,
  copies land next to the original, leading-dot folder names, tabs follow moved files

Co-Authored-By: Claude Opus 5.5 <noreply@anthropic.com>
</commit_message>
<xml_diff>
--- a/examples/E1/ejemplo-biblioya-e1-presentacion.pptx
+++ b/examples/E1/ejemplo-biblioya-e1-presentacion.pptx
@@ -1508,7 +1508,7 @@
                 <a:ea typeface="Calibri" pitchFamily="34" charset="-122"/>
                 <a:cs typeface="Calibri" pitchFamily="34" charset="-120"/>
               </a:rPr>
-              <a:t>20 de octubre de 2026</a:t>
+              <a:t>23 de octubre de 2026</a:t>
             </a:r>
             <a:endParaRPr lang="en-US" sz="1800" dirty="0"/>
           </a:p>
@@ -2319,8 +2319,8 @@
         </p:blipFill>
         <p:spPr>
           <a:xfrm>
-            <a:off x="2308043" y="1097280"/>
-            <a:ext cx="7575610" cy="5166360"/>
+            <a:off x="2130026" y="1097280"/>
+            <a:ext cx="7931644" cy="5166360"/>
           </a:xfrm>
           <a:prstGeom prst="rect">
             <a:avLst/>

</xml_diff>